<commit_message>
Health Checker deck: remove working-title text
</commit_message>
<xml_diff>
--- a/decks/AI-Agent-Health-Checker-Executive-Deck.pptx
+++ b/decks/AI-Agent-Health-Checker-Executive-Deck.pptx
@@ -530,12 +530,6 @@
             <a:r>
               <a:rPr lang="en-US" dirty="0"/>
               <a:t>The case study is a fictional, controlled test (Example Family Dental, scripted rule-based bot, local-only server).</a:t>
-            </a:r>
-          </a:p>
-          <a:p>
-            <a:r>
-              <a:rPr lang="en-US" dirty="0"/>
-              <a:t>'SMB Agent Ops' is only the working name. Live titles: 'AI Agent Health Checker' (/agent-health-checker/) and 'Case study: testing a fictional dental office's chatbot' (/case-study/).</a:t>
             </a:r>
           </a:p>
           <a:p>
@@ -2640,7 +2634,7 @@
                 <a:ea typeface="IBM Plex Mono" pitchFamily="34" charset="-122"/>
                 <a:cs typeface="IBM Plex Mono" pitchFamily="34" charset="-120"/>
               </a:rPr>
-              <a:t>PERSONAL PROJECT · CASE STUDY · WORKING TITLE: SMB AGENT OPS</a:t>
+              <a:t>PERSONAL PROJECT · CASE STUDY</a:t>
             </a:r>
             <a:endParaRPr lang="en-US" sz="1300" dirty="0"/>
           </a:p>

</xml_diff>